<commit_message>
Machine Learning 2hr 10 mins Edureka (KFold, Linear_Regression, Logistic, Kmeans, Titanic_Data)
</commit_message>
<xml_diff>
--- a/SQL_Data_Analytics_Portfolio_Project_2024/SQL PORTFOLIO PROJECT.pptx
+++ b/SQL_Data_Analytics_Portfolio_Project_2024/SQL PORTFOLIO PROJECT.pptx
@@ -257,7 +257,7 @@
           <a:p>
             <a:fld id="{9184DA70-C731-4C70-880D-CCD4705E623C}" type="datetime1">
               <a:rPr lang="en-US" smtClean="0"/>
-              <a:t>4/11/2024</a:t>
+              <a:t>4/17/2024</a:t>
             </a:fld>
             <a:endParaRPr lang="en-US" dirty="0"/>
           </a:p>
@@ -427,7 +427,7 @@
           <a:p>
             <a:fld id="{B612A279-0833-481D-8C56-F67FD0AC6C50}" type="datetime1">
               <a:rPr lang="en-US" smtClean="0"/>
-              <a:t>4/11/2024</a:t>
+              <a:t>4/17/2024</a:t>
             </a:fld>
             <a:endParaRPr lang="en-US" dirty="0"/>
           </a:p>
@@ -607,7 +607,7 @@
           <a:p>
             <a:fld id="{6587DA83-5663-4C9C-B9AA-0B40A3DAFF81}" type="datetime1">
               <a:rPr lang="en-US" smtClean="0"/>
-              <a:t>4/11/2024</a:t>
+              <a:t>4/17/2024</a:t>
             </a:fld>
             <a:endParaRPr lang="en-US" dirty="0"/>
           </a:p>
@@ -777,7 +777,7 @@
           <a:p>
             <a:fld id="{4BE1D723-8F53-4F53-90B0-1982A396982E}" type="datetime1">
               <a:rPr lang="en-US" smtClean="0"/>
-              <a:t>4/11/2024</a:t>
+              <a:t>4/17/2024</a:t>
             </a:fld>
             <a:endParaRPr lang="en-US" dirty="0"/>
           </a:p>
@@ -1023,7 +1023,7 @@
           <a:p>
             <a:fld id="{97669AF7-7BEB-44E4-9852-375E34362B5B}" type="datetime1">
               <a:rPr lang="en-US" smtClean="0"/>
-              <a:t>4/11/2024</a:t>
+              <a:t>4/17/2024</a:t>
             </a:fld>
             <a:endParaRPr lang="en-US" dirty="0"/>
           </a:p>
@@ -1255,7 +1255,7 @@
           <a:p>
             <a:fld id="{BAAAC38D-0552-4C82-B593-E6124DFADBE2}" type="datetime1">
               <a:rPr lang="en-US" smtClean="0"/>
-              <a:t>4/11/2024</a:t>
+              <a:t>4/17/2024</a:t>
             </a:fld>
             <a:endParaRPr lang="en-US" dirty="0"/>
           </a:p>
@@ -1622,7 +1622,7 @@
           <a:p>
             <a:fld id="{D9DF0F1C-5577-4ACB-BB62-DF8F3C494C7E}" type="datetime1">
               <a:rPr lang="en-US" smtClean="0"/>
-              <a:t>4/11/2024</a:t>
+              <a:t>4/17/2024</a:t>
             </a:fld>
             <a:endParaRPr lang="en-US" dirty="0"/>
           </a:p>
@@ -1740,7 +1740,7 @@
           <a:p>
             <a:fld id="{1775B394-D9F9-4F0C-B15D-605F45CB9E9F}" type="datetime1">
               <a:rPr lang="en-US" smtClean="0"/>
-              <a:t>4/11/2024</a:t>
+              <a:t>4/17/2024</a:t>
             </a:fld>
             <a:endParaRPr lang="en-US" dirty="0"/>
           </a:p>
@@ -1835,7 +1835,7 @@
           <a:p>
             <a:fld id="{39667345-2558-425A-8533-9BFDBCE15005}" type="datetime1">
               <a:rPr lang="en-US" smtClean="0"/>
-              <a:t>4/11/2024</a:t>
+              <a:t>4/17/2024</a:t>
             </a:fld>
             <a:endParaRPr lang="en-US" dirty="0"/>
           </a:p>
@@ -2112,7 +2112,7 @@
           <a:p>
             <a:fld id="{92BEA474-078D-4E9B-9B14-09A87B19DC46}" type="datetime1">
               <a:rPr lang="en-US" smtClean="0"/>
-              <a:t>4/11/2024</a:t>
+              <a:t>4/17/2024</a:t>
             </a:fld>
             <a:endParaRPr lang="en-US" dirty="0"/>
           </a:p>
@@ -2370,7 +2370,7 @@
           <a:p>
             <a:fld id="{4907D986-8816-4272-A432-0437A28A9828}" type="datetime1">
               <a:rPr lang="en-US" smtClean="0"/>
-              <a:t>4/11/2024</a:t>
+              <a:t>4/17/2024</a:t>
             </a:fld>
             <a:endParaRPr lang="en-US" dirty="0"/>
           </a:p>
@@ -2584,7 +2584,7 @@
           <a:p>
             <a:fld id="{62D6E202-B606-4609-B914-27C9371A1F6D}" type="datetime1">
               <a:rPr lang="en-US" smtClean="0"/>
-              <a:t>4/11/2024</a:t>
+              <a:t>4/17/2024</a:t>
             </a:fld>
             <a:endParaRPr lang="en-US" dirty="0"/>
           </a:p>
@@ -5449,15 +5449,6 @@
 </file>
 
 <file path=customXml/item1.xml><?xml version="1.0" encoding="utf-8"?>
-<?mso-contentType ?>
-<FormTemplates xmlns="http://schemas.microsoft.com/sharepoint/v3/contenttype/forms">
-  <Display>DocumentLibraryForm</Display>
-  <Edit>DocumentLibraryForm</Edit>
-  <New>DocumentLibraryForm</New>
-</FormTemplates>
-</file>
-
-<file path=customXml/item2.xml><?xml version="1.0" encoding="utf-8"?>
 <p:properties xmlns:p="http://schemas.microsoft.com/office/2006/metadata/properties" xmlns:xsi="http://www.w3.org/2001/XMLSchema-instance" xmlns:pc="http://schemas.microsoft.com/office/infopath/2007/PartnerControls">
   <documentManagement>
     <_ip_UnifiedCompliancePolicyUIAction xmlns="http://schemas.microsoft.com/sharepoint/v3" xsi:nil="true"/>
@@ -5475,6 +5466,15 @@
     <MediaServiceKeyPoints xmlns="71af3243-3dd4-4a8d-8c0d-dd76da1f02a5" xsi:nil="true"/>
   </documentManagement>
 </p:properties>
+</file>
+
+<file path=customXml/item2.xml><?xml version="1.0" encoding="utf-8"?>
+<?mso-contentType ?>
+<FormTemplates xmlns="http://schemas.microsoft.com/sharepoint/v3/contenttype/forms">
+  <Display>DocumentLibraryForm</Display>
+  <Edit>DocumentLibraryForm</Edit>
+  <New>DocumentLibraryForm</New>
+</FormTemplates>
 </file>
 
 <file path=customXml/item3.xml><?xml version="1.0" encoding="utf-8"?>
@@ -5784,21 +5784,28 @@
 </file>
 
 <file path=customXml/itemProps1.xml><?xml version="1.0" encoding="utf-8"?>
-<ds:datastoreItem xmlns:ds="http://schemas.openxmlformats.org/officeDocument/2006/customXml" ds:itemID="{19DAD249-BF80-48EF-9AFB-36A11BCDC2CE}">
+<ds:datastoreItem xmlns:ds="http://schemas.openxmlformats.org/officeDocument/2006/customXml" ds:itemID="{6F4F4D41-822D-40F2-A7AC-E4E6CB36CA7A}">
   <ds:schemaRefs>
-    <ds:schemaRef ds:uri="http://schemas.microsoft.com/sharepoint/v3/contenttype/forms"/>
+    <ds:schemaRef ds:uri="16c05727-aa75-4e4a-9b5f-8a80a1165891"/>
+    <ds:schemaRef ds:uri="71af3243-3dd4-4a8d-8c0d-dd76da1f02a5"/>
+    <ds:schemaRef ds:uri="http://schemas.microsoft.com/office/2006/documentManagement/types"/>
+    <ds:schemaRef ds:uri="http://schemas.microsoft.com/office/infopath/2007/PartnerControls"/>
+    <ds:schemaRef ds:uri="http://purl.org/dc/dcmitype/"/>
+    <ds:schemaRef ds:uri="230e9df3-be65-4c73-a93b-d1236ebd677e"/>
+    <ds:schemaRef ds:uri="http://schemas.openxmlformats.org/package/2006/metadata/core-properties"/>
+    <ds:schemaRef ds:uri="http://schemas.microsoft.com/office/2006/metadata/properties"/>
+    <ds:schemaRef ds:uri="http://purl.org/dc/elements/1.1/"/>
+    <ds:schemaRef ds:uri="http://schemas.microsoft.com/sharepoint/v3"/>
+    <ds:schemaRef ds:uri="http://www.w3.org/XML/1998/namespace"/>
+    <ds:schemaRef ds:uri="http://purl.org/dc/terms/"/>
   </ds:schemaRefs>
 </ds:datastoreItem>
 </file>
 
 <file path=customXml/itemProps2.xml><?xml version="1.0" encoding="utf-8"?>
-<ds:datastoreItem xmlns:ds="http://schemas.openxmlformats.org/officeDocument/2006/customXml" ds:itemID="{6F4F4D41-822D-40F2-A7AC-E4E6CB36CA7A}">
+<ds:datastoreItem xmlns:ds="http://schemas.openxmlformats.org/officeDocument/2006/customXml" ds:itemID="{19DAD249-BF80-48EF-9AFB-36A11BCDC2CE}">
   <ds:schemaRefs>
-    <ds:schemaRef ds:uri="http://schemas.microsoft.com/office/2006/metadata/properties"/>
-    <ds:schemaRef ds:uri="http://schemas.microsoft.com/office/infopath/2007/PartnerControls"/>
-    <ds:schemaRef ds:uri="http://schemas.microsoft.com/sharepoint/v3"/>
-    <ds:schemaRef ds:uri="71af3243-3dd4-4a8d-8c0d-dd76da1f02a5"/>
-    <ds:schemaRef ds:uri="230e9df3-be65-4c73-a93b-d1236ebd677e"/>
+    <ds:schemaRef ds:uri="http://schemas.microsoft.com/sharepoint/v3/contenttype/forms"/>
   </ds:schemaRefs>
 </ds:datastoreItem>
 </file>

</xml_diff>